<commit_message>
Carry the professors' findings into the artifacts, and close the gaps found doing it
Jeske's assay conditions now travel into the exported model (ADR 0113);
Bakker's tie is run through the model without becoming an ensemble (0111);
preparation state, pooled tissues, CC BY attribution, citation export.

Plus the defects found while building those: an audit that passed on an
empty document (0105), a BibTeX key that corrupted every entry after the
27th (0107), a count written into a sentence (0103).
</commit_message>
<xml_diff>
--- a/terrium_pitch_deck.pptx
+++ b/terrium_pitch_deck.pptx
@@ -2060,6 +2060,10 @@
             </a:outerShdw>
           </a:effectLst>
         </p:spPr>
+        <p:txBody>
+          <a:bodyPr/>
+          <a:p/>
+        </p:txBody>
       </p:sp>
       <p:pic>
         <p:nvPicPr>
@@ -2359,6 +2363,10 @@
             </a:outerShdw>
           </a:effectLst>
         </p:spPr>
+        <p:txBody>
+          <a:bodyPr/>
+          <a:p/>
+        </p:txBody>
       </p:sp>
       <p:sp>
         <p:nvSpPr>
@@ -2513,6 +2521,10 @@
             </a:outerShdw>
           </a:effectLst>
         </p:spPr>
+        <p:txBody>
+          <a:bodyPr/>
+          <a:p/>
+        </p:txBody>
       </p:sp>
       <p:sp>
         <p:nvSpPr>
@@ -2667,6 +2679,10 @@
             </a:outerShdw>
           </a:effectLst>
         </p:spPr>
+        <p:txBody>
+          <a:bodyPr/>
+          <a:p/>
+        </p:txBody>
       </p:sp>
       <p:sp>
         <p:nvSpPr>
@@ -2995,6 +3011,10 @@
           </a:solidFill>
           <a:ln/>
         </p:spPr>
+        <p:txBody>
+          <a:bodyPr/>
+          <a:p/>
+        </p:txBody>
       </p:sp>
       <p:sp>
         <p:nvSpPr>
@@ -3110,7 +3130,7 @@
                 <a:ea typeface="Calibri" pitchFamily="34" charset="-122"/>
                 <a:cs typeface="Calibri" pitchFamily="34" charset="-120"/>
               </a:rPr>
-              <a:t>BRENDA/KEGG scraper + simulation engine, CI running, 382 tests passing</a:t>
+              <a:t>BRENDA/KEGG scraper + simulation engine, CI running, 1,852 tests passing</a:t>
             </a:r>
             <a:endParaRPr lang="en-US" sz="1250" dirty="0"/>
           </a:p>
@@ -3135,6 +3155,10 @@
           </a:solidFill>
           <a:ln/>
         </p:spPr>
+        <p:txBody>
+          <a:bodyPr/>
+          <a:p/>
+        </p:txBody>
       </p:sp>
       <p:sp>
         <p:nvSpPr>
@@ -3275,6 +3299,10 @@
           </a:solidFill>
           <a:ln/>
         </p:spPr>
+        <p:txBody>
+          <a:bodyPr/>
+          <a:p/>
+        </p:txBody>
       </p:sp>
       <p:sp>
         <p:nvSpPr>
@@ -3415,6 +3443,10 @@
           </a:solidFill>
           <a:ln/>
         </p:spPr>
+        <p:txBody>
+          <a:bodyPr/>
+          <a:p/>
+        </p:txBody>
       </p:sp>
       <p:sp>
         <p:nvSpPr>
@@ -3711,6 +3743,10 @@
             <a:prstDash val="solid"/>
           </a:ln>
         </p:spPr>
+        <p:txBody>
+          <a:bodyPr/>
+          <a:p/>
+        </p:txBody>
       </p:sp>
       <p:sp>
         <p:nvSpPr>
@@ -3731,6 +3767,10 @@
           </a:solidFill>
           <a:ln/>
         </p:spPr>
+        <p:txBody>
+          <a:bodyPr/>
+          <a:p/>
+        </p:txBody>
       </p:sp>
       <p:sp>
         <p:nvSpPr>
@@ -3917,6 +3957,10 @@
             <a:prstDash val="solid"/>
           </a:ln>
         </p:spPr>
+        <p:txBody>
+          <a:bodyPr/>
+          <a:p/>
+        </p:txBody>
       </p:sp>
       <p:sp>
         <p:nvSpPr>
@@ -3937,6 +3981,10 @@
           </a:solidFill>
           <a:ln/>
         </p:spPr>
+        <p:txBody>
+          <a:bodyPr/>
+          <a:p/>
+        </p:txBody>
       </p:sp>
       <p:sp>
         <p:nvSpPr>
@@ -4123,6 +4171,10 @@
             <a:prstDash val="solid"/>
           </a:ln>
         </p:spPr>
+        <p:txBody>
+          <a:bodyPr/>
+          <a:p/>
+        </p:txBody>
       </p:sp>
       <p:sp>
         <p:nvSpPr>
@@ -4143,6 +4195,10 @@
           </a:solidFill>
           <a:ln/>
         </p:spPr>
+        <p:txBody>
+          <a:bodyPr/>
+          <a:p/>
+        </p:txBody>
       </p:sp>
       <p:sp>
         <p:nvSpPr>
@@ -4329,6 +4385,10 @@
             <a:prstDash val="solid"/>
           </a:ln>
         </p:spPr>
+        <p:txBody>
+          <a:bodyPr/>
+          <a:p/>
+        </p:txBody>
       </p:sp>
       <p:sp>
         <p:nvSpPr>
@@ -4349,6 +4409,10 @@
           </a:solidFill>
           <a:ln/>
         </p:spPr>
+        <p:txBody>
+          <a:bodyPr/>
+          <a:p/>
+        </p:txBody>
       </p:sp>
       <p:sp>
         <p:nvSpPr>
@@ -4682,6 +4746,10 @@
             <a:prstDash val="solid"/>
           </a:ln>
         </p:spPr>
+        <p:txBody>
+          <a:bodyPr/>
+          <a:p/>
+        </p:txBody>
       </p:sp>
       <p:sp>
         <p:nvSpPr>
@@ -4866,6 +4934,10 @@
             <a:prstDash val="solid"/>
           </a:ln>
         </p:spPr>
+        <p:txBody>
+          <a:bodyPr/>
+          <a:p/>
+        </p:txBody>
       </p:sp>
       <p:sp>
         <p:nvSpPr>
@@ -5050,6 +5122,10 @@
             <a:prstDash val="solid"/>
           </a:ln>
         </p:spPr>
+        <p:txBody>
+          <a:bodyPr/>
+          <a:p/>
+        </p:txBody>
       </p:sp>
       <p:sp>
         <p:nvSpPr>
@@ -5400,6 +5476,10 @@
           </a:solidFill>
           <a:ln/>
         </p:spPr>
+        <p:txBody>
+          <a:bodyPr/>
+          <a:p/>
+        </p:txBody>
       </p:sp>
       <p:sp>
         <p:nvSpPr>
@@ -5500,6 +5580,10 @@
           </a:solidFill>
           <a:ln/>
         </p:spPr>
+        <p:txBody>
+          <a:bodyPr/>
+          <a:p/>
+        </p:txBody>
       </p:sp>
       <p:sp>
         <p:nvSpPr>
@@ -5600,6 +5684,10 @@
           </a:solidFill>
           <a:ln/>
         </p:spPr>
+        <p:txBody>
+          <a:bodyPr/>
+          <a:p/>
+        </p:txBody>
       </p:sp>
       <p:sp>
         <p:nvSpPr>
@@ -5900,6 +5988,10 @@
             </a:outerShdw>
           </a:effectLst>
         </p:spPr>
+        <p:txBody>
+          <a:bodyPr/>
+          <a:p/>
+        </p:txBody>
       </p:sp>
       <p:sp>
         <p:nvSpPr>
@@ -6015,6 +6107,10 @@
             </a:outerShdw>
           </a:effectLst>
         </p:spPr>
+        <p:txBody>
+          <a:bodyPr/>
+          <a:p/>
+        </p:txBody>
       </p:sp>
       <p:sp>
         <p:nvSpPr>
@@ -6362,6 +6458,10 @@
           </a:solidFill>
           <a:ln/>
         </p:spPr>
+        <p:txBody>
+          <a:bodyPr/>
+          <a:p/>
+        </p:txBody>
       </p:sp>
       <p:sp>
         <p:nvSpPr>
@@ -6504,6 +6604,10 @@
           </a:solidFill>
           <a:ln/>
         </p:spPr>
+        <p:txBody>
+          <a:bodyPr/>
+          <a:p/>
+        </p:txBody>
       </p:sp>
       <p:sp>
         <p:nvSpPr>
@@ -6646,6 +6750,10 @@
           </a:solidFill>
           <a:ln/>
         </p:spPr>
+        <p:txBody>
+          <a:bodyPr/>
+          <a:p/>
+        </p:txBody>
       </p:sp>
       <p:sp>
         <p:nvSpPr>
@@ -6788,6 +6896,10 @@
           </a:solidFill>
           <a:ln/>
         </p:spPr>
+        <p:txBody>
+          <a:bodyPr/>
+          <a:p/>
+        </p:txBody>
       </p:sp>
       <p:sp>
         <p:nvSpPr>
@@ -7231,6 +7343,10 @@
             <a:prstDash val="solid"/>
           </a:ln>
         </p:spPr>
+        <p:txBody>
+          <a:bodyPr/>
+          <a:p/>
+        </p:txBody>
       </p:sp>
       <p:sp>
         <p:nvSpPr>
@@ -7251,6 +7367,10 @@
           </a:solidFill>
           <a:ln/>
         </p:spPr>
+        <p:txBody>
+          <a:bodyPr/>
+          <a:p/>
+        </p:txBody>
       </p:sp>
       <p:sp>
         <p:nvSpPr>
@@ -7398,6 +7518,10 @@
             <a:prstDash val="solid"/>
           </a:ln>
         </p:spPr>
+        <p:txBody>
+          <a:bodyPr/>
+          <a:p/>
+        </p:txBody>
       </p:sp>
       <p:sp>
         <p:nvSpPr>
@@ -7418,6 +7542,10 @@
           </a:solidFill>
           <a:ln/>
         </p:spPr>
+        <p:txBody>
+          <a:bodyPr/>
+          <a:p/>
+        </p:txBody>
       </p:sp>
       <p:sp>
         <p:nvSpPr>
@@ -7565,6 +7693,10 @@
             <a:prstDash val="solid"/>
           </a:ln>
         </p:spPr>
+        <p:txBody>
+          <a:bodyPr/>
+          <a:p/>
+        </p:txBody>
       </p:sp>
       <p:sp>
         <p:nvSpPr>
@@ -7585,6 +7717,10 @@
           </a:solidFill>
           <a:ln/>
         </p:spPr>
+        <p:txBody>
+          <a:bodyPr/>
+          <a:p/>
+        </p:txBody>
       </p:sp>
       <p:sp>
         <p:nvSpPr>
@@ -7732,6 +7868,10 @@
             <a:prstDash val="solid"/>
           </a:ln>
         </p:spPr>
+        <p:txBody>
+          <a:bodyPr/>
+          <a:p/>
+        </p:txBody>
       </p:sp>
       <p:sp>
         <p:nvSpPr>
@@ -7752,6 +7892,10 @@
           </a:solidFill>
           <a:ln/>
         </p:spPr>
+        <p:txBody>
+          <a:bodyPr/>
+          <a:p/>
+        </p:txBody>
       </p:sp>
       <p:sp>
         <p:nvSpPr>
@@ -7899,6 +8043,10 @@
             <a:prstDash val="solid"/>
           </a:ln>
         </p:spPr>
+        <p:txBody>
+          <a:bodyPr/>
+          <a:p/>
+        </p:txBody>
       </p:sp>
       <p:sp>
         <p:nvSpPr>
@@ -7919,6 +8067,10 @@
           </a:solidFill>
           <a:ln/>
         </p:spPr>
+        <p:txBody>
+          <a:bodyPr/>
+          <a:p/>
+        </p:txBody>
       </p:sp>
       <p:sp>
         <p:nvSpPr>
@@ -8066,6 +8218,10 @@
             <a:prstDash val="solid"/>
           </a:ln>
         </p:spPr>
+        <p:txBody>
+          <a:bodyPr/>
+          <a:p/>
+        </p:txBody>
       </p:sp>
       <p:sp>
         <p:nvSpPr>
@@ -8086,6 +8242,10 @@
           </a:solidFill>
           <a:ln/>
         </p:spPr>
+        <p:txBody>
+          <a:bodyPr/>
+          <a:p/>
+        </p:txBody>
       </p:sp>
       <p:sp>
         <p:nvSpPr>
@@ -8416,6 +8576,10 @@
           </a:solidFill>
           <a:ln/>
         </p:spPr>
+        <p:txBody>
+          <a:bodyPr/>
+          <a:p/>
+        </p:txBody>
       </p:sp>
       <p:sp>
         <p:nvSpPr>
@@ -8516,6 +8680,10 @@
           </a:solidFill>
           <a:ln/>
         </p:spPr>
+        <p:txBody>
+          <a:bodyPr/>
+          <a:p/>
+        </p:txBody>
       </p:sp>
       <p:sp>
         <p:nvSpPr>
@@ -8577,6 +8745,10 @@
           </a:solidFill>
           <a:ln/>
         </p:spPr>
+        <p:txBody>
+          <a:bodyPr/>
+          <a:p/>
+        </p:txBody>
       </p:sp>
       <p:sp>
         <p:nvSpPr>
@@ -8677,6 +8849,10 @@
           </a:solidFill>
           <a:ln/>
         </p:spPr>
+        <p:txBody>
+          <a:bodyPr/>
+          <a:p/>
+        </p:txBody>
       </p:sp>
       <p:sp>
         <p:nvSpPr>
@@ -8738,6 +8914,10 @@
           </a:solidFill>
           <a:ln/>
         </p:spPr>
+        <p:txBody>
+          <a:bodyPr/>
+          <a:p/>
+        </p:txBody>
       </p:sp>
       <p:sp>
         <p:nvSpPr>
@@ -8838,6 +9018,10 @@
           </a:solidFill>
           <a:ln/>
         </p:spPr>
+        <p:txBody>
+          <a:bodyPr/>
+          <a:p/>
+        </p:txBody>
       </p:sp>
       <p:sp>
         <p:nvSpPr>
@@ -8899,6 +9083,10 @@
           </a:solidFill>
           <a:ln/>
         </p:spPr>
+        <p:txBody>
+          <a:bodyPr/>
+          <a:p/>
+        </p:txBody>
       </p:sp>
       <p:sp>
         <p:nvSpPr>
@@ -8999,6 +9187,10 @@
           </a:solidFill>
           <a:ln/>
         </p:spPr>
+        <p:txBody>
+          <a:bodyPr/>
+          <a:p/>
+        </p:txBody>
       </p:sp>
       <p:sp>
         <p:nvSpPr>
@@ -9060,6 +9252,10 @@
           </a:solidFill>
           <a:ln/>
         </p:spPr>
+        <p:txBody>
+          <a:bodyPr/>
+          <a:p/>
+        </p:txBody>
       </p:sp>
       <p:sp>
         <p:nvSpPr>
@@ -9160,6 +9356,10 @@
           </a:solidFill>
           <a:ln/>
         </p:spPr>
+        <p:txBody>
+          <a:bodyPr/>
+          <a:p/>
+        </p:txBody>
       </p:sp>
       <p:sp>
         <p:nvSpPr>
@@ -9221,6 +9421,10 @@
           </a:solidFill>
           <a:ln/>
         </p:spPr>
+        <p:txBody>
+          <a:bodyPr/>
+          <a:p/>
+        </p:txBody>
       </p:sp>
       <p:sp>
         <p:nvSpPr>
@@ -9321,6 +9525,10 @@
           </a:solidFill>
           <a:ln/>
         </p:spPr>
+        <p:txBody>
+          <a:bodyPr/>
+          <a:p/>
+        </p:txBody>
       </p:sp>
       <p:sp>
         <p:nvSpPr>
@@ -9543,7 +9751,7 @@
                 <a:ea typeface="Cambria" pitchFamily="34" charset="-122"/>
                 <a:cs typeface="Cambria" pitchFamily="34" charset="-120"/>
               </a:rPr>
-              <a:t>382</a:t>
+              <a:t>1,852</a:t>
             </a:r>
             <a:endParaRPr lang="en-US" sz="5200" dirty="0"/>
           </a:p>
@@ -9779,6 +9987,10 @@
             <a:prstDash val="solid"/>
           </a:ln>
         </p:spPr>
+        <p:txBody>
+          <a:bodyPr/>
+          <a:p/>
+        </p:txBody>
       </p:sp>
       <p:sp>
         <p:nvSpPr>
@@ -10031,6 +10243,10 @@
           </a:solidFill>
           <a:ln/>
         </p:spPr>
+        <p:txBody>
+          <a:bodyPr/>
+          <a:p/>
+        </p:txBody>
       </p:sp>
       <p:sp>
         <p:nvSpPr>
@@ -10134,6 +10350,10 @@
           </a:solidFill>
           <a:ln/>
         </p:spPr>
+        <p:txBody>
+          <a:bodyPr/>
+          <a:p/>
+        </p:txBody>
       </p:sp>
       <p:sp>
         <p:nvSpPr>
@@ -10237,6 +10457,10 @@
           </a:solidFill>
           <a:ln/>
         </p:spPr>
+        <p:txBody>
+          <a:bodyPr/>
+          <a:p/>
+        </p:txBody>
       </p:sp>
       <p:sp>
         <p:nvSpPr>
@@ -10487,6 +10711,10 @@
           </a:solidFill>
           <a:ln/>
         </p:spPr>
+        <p:txBody>
+          <a:bodyPr/>
+          <a:p/>
+        </p:txBody>
       </p:sp>
       <p:sp>
         <p:nvSpPr>
@@ -10507,6 +10735,10 @@
           </a:solidFill>
           <a:ln/>
         </p:spPr>
+        <p:txBody>
+          <a:bodyPr/>
+          <a:p/>
+        </p:txBody>
       </p:sp>
       <p:sp>
         <p:nvSpPr>
@@ -10527,6 +10759,10 @@
           </a:solidFill>
           <a:ln/>
         </p:spPr>
+        <p:txBody>
+          <a:bodyPr/>
+          <a:p/>
+        </p:txBody>
       </p:sp>
       <p:sp>
         <p:nvSpPr>
@@ -11055,6 +11291,10 @@
             <a:prstDash val="solid"/>
           </a:ln>
         </p:spPr>
+        <p:txBody>
+          <a:bodyPr/>
+          <a:p/>
+        </p:txBody>
       </p:sp>
       <p:sp>
         <p:nvSpPr>
@@ -11111,6 +11351,10 @@
             <a:prstDash val="solid"/>
           </a:ln>
         </p:spPr>
+        <p:txBody>
+          <a:bodyPr/>
+          <a:p/>
+        </p:txBody>
       </p:sp>
       <p:sp>
         <p:nvSpPr>
@@ -11178,6 +11422,10 @@
             <a:prstDash val="solid"/>
           </a:ln>
         </p:spPr>
+        <p:txBody>
+          <a:bodyPr/>
+          <a:p/>
+        </p:txBody>
       </p:sp>
       <p:sp>
         <p:nvSpPr>
@@ -11245,6 +11493,10 @@
             <a:prstDash val="solid"/>
           </a:ln>
         </p:spPr>
+        <p:txBody>
+          <a:bodyPr/>
+          <a:p/>
+        </p:txBody>
       </p:sp>
       <p:sp>
         <p:nvSpPr>
@@ -11312,6 +11564,10 @@
             <a:prstDash val="solid"/>
           </a:ln>
         </p:spPr>
+        <p:txBody>
+          <a:bodyPr/>
+          <a:p/>
+        </p:txBody>
       </p:sp>
       <p:sp>
         <p:nvSpPr>
@@ -11379,6 +11635,10 @@
             <a:prstDash val="solid"/>
           </a:ln>
         </p:spPr>
+        <p:txBody>
+          <a:bodyPr/>
+          <a:p/>
+        </p:txBody>
       </p:sp>
       <p:sp>
         <p:nvSpPr>
@@ -11446,6 +11706,10 @@
             <a:prstDash val="solid"/>
           </a:ln>
         </p:spPr>
+        <p:txBody>
+          <a:bodyPr/>
+          <a:p/>
+        </p:txBody>
       </p:sp>
       <p:sp>
         <p:nvSpPr>
@@ -11513,6 +11777,10 @@
             <a:prstDash val="solid"/>
           </a:ln>
         </p:spPr>
+        <p:txBody>
+          <a:bodyPr/>
+          <a:p/>
+        </p:txBody>
       </p:sp>
       <p:sp>
         <p:nvSpPr>
@@ -11580,6 +11848,10 @@
             <a:prstDash val="solid"/>
           </a:ln>
         </p:spPr>
+        <p:txBody>
+          <a:bodyPr/>
+          <a:p/>
+        </p:txBody>
       </p:sp>
       <p:sp>
         <p:nvSpPr>
@@ -11647,6 +11919,10 @@
             <a:prstDash val="solid"/>
           </a:ln>
         </p:spPr>
+        <p:txBody>
+          <a:bodyPr/>
+          <a:p/>
+        </p:txBody>
       </p:sp>
       <p:sp>
         <p:nvSpPr>
@@ -11714,6 +11990,10 @@
             <a:prstDash val="solid"/>
           </a:ln>
         </p:spPr>
+        <p:txBody>
+          <a:bodyPr/>
+          <a:p/>
+        </p:txBody>
       </p:sp>
       <p:sp>
         <p:nvSpPr>
@@ -11781,6 +12061,10 @@
             <a:prstDash val="solid"/>
           </a:ln>
         </p:spPr>
+        <p:txBody>
+          <a:bodyPr/>
+          <a:p/>
+        </p:txBody>
       </p:sp>
       <p:sp>
         <p:nvSpPr>
@@ -11848,6 +12132,10 @@
             <a:prstDash val="solid"/>
           </a:ln>
         </p:spPr>
+        <p:txBody>
+          <a:bodyPr/>
+          <a:p/>
+        </p:txBody>
       </p:sp>
       <p:sp>
         <p:nvSpPr>
@@ -11915,6 +12203,10 @@
             <a:prstDash val="solid"/>
           </a:ln>
         </p:spPr>
+        <p:txBody>
+          <a:bodyPr/>
+          <a:p/>
+        </p:txBody>
       </p:sp>
       <p:sp>
         <p:nvSpPr>
@@ -11982,6 +12274,10 @@
             <a:prstDash val="solid"/>
           </a:ln>
         </p:spPr>
+        <p:txBody>
+          <a:bodyPr/>
+          <a:p/>
+        </p:txBody>
       </p:sp>
       <p:sp>
         <p:nvSpPr>
@@ -12049,6 +12345,10 @@
             <a:prstDash val="solid"/>
           </a:ln>
         </p:spPr>
+        <p:txBody>
+          <a:bodyPr/>
+          <a:p/>
+        </p:txBody>
       </p:sp>
       <p:sp>
         <p:nvSpPr>
@@ -12116,6 +12416,10 @@
             <a:prstDash val="solid"/>
           </a:ln>
         </p:spPr>
+        <p:txBody>
+          <a:bodyPr/>
+          <a:p/>
+        </p:txBody>
       </p:sp>
       <p:sp>
         <p:nvSpPr>
@@ -12183,6 +12487,10 @@
             <a:prstDash val="solid"/>
           </a:ln>
         </p:spPr>
+        <p:txBody>
+          <a:bodyPr/>
+          <a:p/>
+        </p:txBody>
       </p:sp>
       <p:sp>
         <p:nvSpPr>
@@ -12250,6 +12558,10 @@
             <a:prstDash val="solid"/>
           </a:ln>
         </p:spPr>
+        <p:txBody>
+          <a:bodyPr/>
+          <a:p/>
+        </p:txBody>
       </p:sp>
       <p:sp>
         <p:nvSpPr>
@@ -12317,6 +12629,10 @@
             <a:prstDash val="solid"/>
           </a:ln>
         </p:spPr>
+        <p:txBody>
+          <a:bodyPr/>
+          <a:p/>
+        </p:txBody>
       </p:sp>
       <p:sp>
         <p:nvSpPr>

</xml_diff>